<commit_message>
Session handoff: update pptx, rospatent PDFs
Co-Authored-By: Claude Sonnet 4.6 <noreply@anthropic.com>
</commit_message>
<xml_diff>
--- a/presentation/user-cases.pptx
+++ b/presentation/user-cases.pptx
@@ -5,20 +5,20 @@
     <p:sldMasterId id="2147483648" r:id="rId1"/>
   </p:sldMasterIdLst>
   <p:sldIdLst>
-    <p:sldId id="256" r:id="rId7"/>
-    <p:sldId id="257" r:id="rId8"/>
-    <p:sldId id="258" r:id="rId9"/>
-    <p:sldId id="259" r:id="rId10"/>
-    <p:sldId id="260" r:id="rId11"/>
-    <p:sldId id="261" r:id="rId12"/>
-    <p:sldId id="262" r:id="rId13"/>
-    <p:sldId id="263" r:id="rId14"/>
-    <p:sldId id="264" r:id="rId15"/>
-    <p:sldId id="265" r:id="rId16"/>
-    <p:sldId id="266" r:id="rId17"/>
-    <p:sldId id="267" r:id="rId18"/>
+    <p:sldId id="256" r:id="rId2"/>
+    <p:sldId id="257" r:id="rId3"/>
+    <p:sldId id="258" r:id="rId4"/>
+    <p:sldId id="259" r:id="rId5"/>
+    <p:sldId id="260" r:id="rId6"/>
+    <p:sldId id="261" r:id="rId7"/>
+    <p:sldId id="262" r:id="rId8"/>
+    <p:sldId id="263" r:id="rId9"/>
+    <p:sldId id="264" r:id="rId10"/>
+    <p:sldId id="265" r:id="rId11"/>
+    <p:sldId id="266" r:id="rId12"/>
+    <p:sldId id="267" r:id="rId13"/>
   </p:sldIdLst>
-  <p:sldSz cx="12191695" cy="6858000" type="screen4x3"/>
+  <p:sldSz cx="12192000" cy="6858000"/>
   <p:notesSz cx="6858000" cy="9144000"/>
   <p:defaultTextStyle>
     <a:defPPr>
@@ -115,6 +115,22 @@
       </a:defRPr>
     </a:lvl9pPr>
   </p:defaultTextStyle>
+  <p:extLst>
+    <p:ext uri="{EFAFB233-063F-42B5-8137-9DF3F51BA10A}">
+      <p15:sldGuideLst xmlns:p15="http://schemas.microsoft.com/office/powerpoint/2012/main">
+        <p15:guide id="1" orient="horz" pos="2160">
+          <p15:clr>
+            <a:srgbClr val="A4A3A4"/>
+          </p15:clr>
+        </p15:guide>
+        <p15:guide id="2" pos="2880">
+          <p15:clr>
+            <a:srgbClr val="A4A3A4"/>
+          </p15:clr>
+        </p15:guide>
+      </p15:sldGuideLst>
+    </p:ext>
+  </p:extLst>
 </p:presentation>
 </file>
 
@@ -156,10 +172,9 @@
           <a:lstStyle/>
           <a:p>
             <a:r>
-              <a:rPr lang="en-US" smtClean="0"/>
+              <a:rPr lang="en-US"/>
               <a:t>Click to edit Master title style</a:t>
             </a:r>
-            <a:endParaRPr lang="en-US"/>
           </a:p>
         </p:txBody>
       </p:sp>
@@ -275,10 +290,9 @@
           </a:lstStyle>
           <a:p>
             <a:r>
-              <a:rPr lang="en-US" smtClean="0"/>
+              <a:rPr lang="en-US"/>
               <a:t>Click to edit Master subtitle style</a:t>
             </a:r>
-            <a:endParaRPr lang="en-US"/>
           </a:p>
         </p:txBody>
       </p:sp>
@@ -299,7 +313,7 @@
           <a:p>
             <a:fld id="{5BCAD085-E8A6-8845-BD4E-CB4CCA059FC4}" type="datetimeFigureOut">
               <a:rPr lang="en-US" smtClean="0"/>
-              <a:t>1/27/13</a:t>
+              <a:t>5/7/26</a:t>
             </a:fld>
             <a:endParaRPr lang="en-US"/>
           </a:p>
@@ -393,10 +407,9 @@
           <a:lstStyle/>
           <a:p>
             <a:r>
-              <a:rPr lang="en-US" smtClean="0"/>
+              <a:rPr lang="en-US"/>
               <a:t>Click to edit Master title style</a:t>
             </a:r>
-            <a:endParaRPr lang="en-US"/>
           </a:p>
         </p:txBody>
       </p:sp>
@@ -417,38 +430,37 @@
           <a:p>
             <a:pPr lvl="0"/>
             <a:r>
-              <a:rPr lang="en-US" smtClean="0"/>
+              <a:rPr lang="en-US"/>
               <a:t>Click to edit Master text styles</a:t>
             </a:r>
           </a:p>
           <a:p>
             <a:pPr lvl="1"/>
             <a:r>
-              <a:rPr lang="en-US" smtClean="0"/>
+              <a:rPr lang="en-US"/>
               <a:t>Second level</a:t>
             </a:r>
           </a:p>
           <a:p>
             <a:pPr lvl="2"/>
             <a:r>
-              <a:rPr lang="en-US" smtClean="0"/>
+              <a:rPr lang="en-US"/>
               <a:t>Third level</a:t>
             </a:r>
           </a:p>
           <a:p>
             <a:pPr lvl="3"/>
             <a:r>
-              <a:rPr lang="en-US" smtClean="0"/>
+              <a:rPr lang="en-US"/>
               <a:t>Fourth level</a:t>
             </a:r>
           </a:p>
           <a:p>
             <a:pPr lvl="4"/>
             <a:r>
-              <a:rPr lang="en-US" smtClean="0"/>
+              <a:rPr lang="en-US"/>
               <a:t>Fifth level</a:t>
             </a:r>
-            <a:endParaRPr lang="en-US"/>
           </a:p>
         </p:txBody>
       </p:sp>
@@ -469,7 +481,7 @@
           <a:p>
             <a:fld id="{5BCAD085-E8A6-8845-BD4E-CB4CCA059FC4}" type="datetimeFigureOut">
               <a:rPr lang="en-US" smtClean="0"/>
-              <a:t>1/27/13</a:t>
+              <a:t>5/7/26</a:t>
             </a:fld>
             <a:endParaRPr lang="en-US"/>
           </a:p>
@@ -568,10 +580,9 @@
           <a:lstStyle/>
           <a:p>
             <a:r>
-              <a:rPr lang="en-US" smtClean="0"/>
+              <a:rPr lang="en-US"/>
               <a:t>Click to edit Master title style</a:t>
             </a:r>
-            <a:endParaRPr lang="en-US"/>
           </a:p>
         </p:txBody>
       </p:sp>
@@ -597,38 +608,37 @@
           <a:p>
             <a:pPr lvl="0"/>
             <a:r>
-              <a:rPr lang="en-US" smtClean="0"/>
+              <a:rPr lang="en-US"/>
               <a:t>Click to edit Master text styles</a:t>
             </a:r>
           </a:p>
           <a:p>
             <a:pPr lvl="1"/>
             <a:r>
-              <a:rPr lang="en-US" smtClean="0"/>
+              <a:rPr lang="en-US"/>
               <a:t>Second level</a:t>
             </a:r>
           </a:p>
           <a:p>
             <a:pPr lvl="2"/>
             <a:r>
-              <a:rPr lang="en-US" smtClean="0"/>
+              <a:rPr lang="en-US"/>
               <a:t>Third level</a:t>
             </a:r>
           </a:p>
           <a:p>
             <a:pPr lvl="3"/>
             <a:r>
-              <a:rPr lang="en-US" smtClean="0"/>
+              <a:rPr lang="en-US"/>
               <a:t>Fourth level</a:t>
             </a:r>
           </a:p>
           <a:p>
             <a:pPr lvl="4"/>
             <a:r>
-              <a:rPr lang="en-US" smtClean="0"/>
+              <a:rPr lang="en-US"/>
               <a:t>Fifth level</a:t>
             </a:r>
-            <a:endParaRPr lang="en-US"/>
           </a:p>
         </p:txBody>
       </p:sp>
@@ -649,7 +659,7 @@
           <a:p>
             <a:fld id="{5BCAD085-E8A6-8845-BD4E-CB4CCA059FC4}" type="datetimeFigureOut">
               <a:rPr lang="en-US" smtClean="0"/>
-              <a:t>1/27/13</a:t>
+              <a:t>5/7/26</a:t>
             </a:fld>
             <a:endParaRPr lang="en-US"/>
           </a:p>
@@ -743,10 +753,9 @@
           <a:lstStyle/>
           <a:p>
             <a:r>
-              <a:rPr lang="en-US" smtClean="0"/>
+              <a:rPr lang="en-US"/>
               <a:t>Click to edit Master title style</a:t>
             </a:r>
-            <a:endParaRPr lang="en-US"/>
           </a:p>
         </p:txBody>
       </p:sp>
@@ -767,38 +776,37 @@
           <a:p>
             <a:pPr lvl="0"/>
             <a:r>
-              <a:rPr lang="en-US" smtClean="0"/>
+              <a:rPr lang="en-US"/>
               <a:t>Click to edit Master text styles</a:t>
             </a:r>
           </a:p>
           <a:p>
             <a:pPr lvl="1"/>
             <a:r>
-              <a:rPr lang="en-US" smtClean="0"/>
+              <a:rPr lang="en-US"/>
               <a:t>Second level</a:t>
             </a:r>
           </a:p>
           <a:p>
             <a:pPr lvl="2"/>
             <a:r>
-              <a:rPr lang="en-US" smtClean="0"/>
+              <a:rPr lang="en-US"/>
               <a:t>Third level</a:t>
             </a:r>
           </a:p>
           <a:p>
             <a:pPr lvl="3"/>
             <a:r>
-              <a:rPr lang="en-US" smtClean="0"/>
+              <a:rPr lang="en-US"/>
               <a:t>Fourth level</a:t>
             </a:r>
           </a:p>
           <a:p>
             <a:pPr lvl="4"/>
             <a:r>
-              <a:rPr lang="en-US" smtClean="0"/>
+              <a:rPr lang="en-US"/>
               <a:t>Fifth level</a:t>
             </a:r>
-            <a:endParaRPr lang="en-US"/>
           </a:p>
         </p:txBody>
       </p:sp>
@@ -819,7 +827,7 @@
           <a:p>
             <a:fld id="{5BCAD085-E8A6-8845-BD4E-CB4CCA059FC4}" type="datetimeFigureOut">
               <a:rPr lang="en-US" smtClean="0"/>
-              <a:t>1/27/13</a:t>
+              <a:t>5/7/26</a:t>
             </a:fld>
             <a:endParaRPr lang="en-US"/>
           </a:p>
@@ -922,10 +930,9 @@
           </a:lstStyle>
           <a:p>
             <a:r>
-              <a:rPr lang="en-US" smtClean="0"/>
+              <a:rPr lang="en-US"/>
               <a:t>Click to edit Master title style</a:t>
             </a:r>
-            <a:endParaRPr lang="en-US"/>
           </a:p>
         </p:txBody>
       </p:sp>
@@ -1042,7 +1049,7 @@
           <a:p>
             <a:pPr lvl="0"/>
             <a:r>
-              <a:rPr lang="en-US" smtClean="0"/>
+              <a:rPr lang="en-US"/>
               <a:t>Click to edit Master text styles</a:t>
             </a:r>
           </a:p>
@@ -1065,7 +1072,7 @@
           <a:p>
             <a:fld id="{5BCAD085-E8A6-8845-BD4E-CB4CCA059FC4}" type="datetimeFigureOut">
               <a:rPr lang="en-US" smtClean="0"/>
-              <a:t>1/27/13</a:t>
+              <a:t>5/7/26</a:t>
             </a:fld>
             <a:endParaRPr lang="en-US"/>
           </a:p>
@@ -1159,10 +1166,9 @@
           <a:lstStyle/>
           <a:p>
             <a:r>
-              <a:rPr lang="en-US" smtClean="0"/>
+              <a:rPr lang="en-US"/>
               <a:t>Click to edit Master title style</a:t>
             </a:r>
-            <a:endParaRPr lang="en-US"/>
           </a:p>
         </p:txBody>
       </p:sp>
@@ -1216,38 +1222,37 @@
           <a:p>
             <a:pPr lvl="0"/>
             <a:r>
-              <a:rPr lang="en-US" smtClean="0"/>
+              <a:rPr lang="en-US"/>
               <a:t>Click to edit Master text styles</a:t>
             </a:r>
           </a:p>
           <a:p>
             <a:pPr lvl="1"/>
             <a:r>
-              <a:rPr lang="en-US" smtClean="0"/>
+              <a:rPr lang="en-US"/>
               <a:t>Second level</a:t>
             </a:r>
           </a:p>
           <a:p>
             <a:pPr lvl="2"/>
             <a:r>
-              <a:rPr lang="en-US" smtClean="0"/>
+              <a:rPr lang="en-US"/>
               <a:t>Third level</a:t>
             </a:r>
           </a:p>
           <a:p>
             <a:pPr lvl="3"/>
             <a:r>
-              <a:rPr lang="en-US" smtClean="0"/>
+              <a:rPr lang="en-US"/>
               <a:t>Fourth level</a:t>
             </a:r>
           </a:p>
           <a:p>
             <a:pPr lvl="4"/>
             <a:r>
-              <a:rPr lang="en-US" smtClean="0"/>
+              <a:rPr lang="en-US"/>
               <a:t>Fifth level</a:t>
             </a:r>
-            <a:endParaRPr lang="en-US"/>
           </a:p>
         </p:txBody>
       </p:sp>
@@ -1301,38 +1306,37 @@
           <a:p>
             <a:pPr lvl="0"/>
             <a:r>
-              <a:rPr lang="en-US" smtClean="0"/>
+              <a:rPr lang="en-US"/>
               <a:t>Click to edit Master text styles</a:t>
             </a:r>
           </a:p>
           <a:p>
             <a:pPr lvl="1"/>
             <a:r>
-              <a:rPr lang="en-US" smtClean="0"/>
+              <a:rPr lang="en-US"/>
               <a:t>Second level</a:t>
             </a:r>
           </a:p>
           <a:p>
             <a:pPr lvl="2"/>
             <a:r>
-              <a:rPr lang="en-US" smtClean="0"/>
+              <a:rPr lang="en-US"/>
               <a:t>Third level</a:t>
             </a:r>
           </a:p>
           <a:p>
             <a:pPr lvl="3"/>
             <a:r>
-              <a:rPr lang="en-US" smtClean="0"/>
+              <a:rPr lang="en-US"/>
               <a:t>Fourth level</a:t>
             </a:r>
           </a:p>
           <a:p>
             <a:pPr lvl="4"/>
             <a:r>
-              <a:rPr lang="en-US" smtClean="0"/>
+              <a:rPr lang="en-US"/>
               <a:t>Fifth level</a:t>
             </a:r>
-            <a:endParaRPr lang="en-US"/>
           </a:p>
         </p:txBody>
       </p:sp>
@@ -1353,7 +1357,7 @@
           <a:p>
             <a:fld id="{5BCAD085-E8A6-8845-BD4E-CB4CCA059FC4}" type="datetimeFigureOut">
               <a:rPr lang="en-US" smtClean="0"/>
-              <a:t>1/27/13</a:t>
+              <a:t>5/7/26</a:t>
             </a:fld>
             <a:endParaRPr lang="en-US"/>
           </a:p>
@@ -1451,10 +1455,9 @@
           </a:lstStyle>
           <a:p>
             <a:r>
-              <a:rPr lang="en-US" smtClean="0"/>
+              <a:rPr lang="en-US"/>
               <a:t>Click to edit Master title style</a:t>
             </a:r>
-            <a:endParaRPr lang="en-US"/>
           </a:p>
         </p:txBody>
       </p:sp>
@@ -1517,7 +1520,7 @@
           <a:p>
             <a:pPr lvl="0"/>
             <a:r>
-              <a:rPr lang="en-US" smtClean="0"/>
+              <a:rPr lang="en-US"/>
               <a:t>Click to edit Master text styles</a:t>
             </a:r>
           </a:p>
@@ -1573,38 +1576,37 @@
           <a:p>
             <a:pPr lvl="0"/>
             <a:r>
-              <a:rPr lang="en-US" smtClean="0"/>
+              <a:rPr lang="en-US"/>
               <a:t>Click to edit Master text styles</a:t>
             </a:r>
           </a:p>
           <a:p>
             <a:pPr lvl="1"/>
             <a:r>
-              <a:rPr lang="en-US" smtClean="0"/>
+              <a:rPr lang="en-US"/>
               <a:t>Second level</a:t>
             </a:r>
           </a:p>
           <a:p>
             <a:pPr lvl="2"/>
             <a:r>
-              <a:rPr lang="en-US" smtClean="0"/>
+              <a:rPr lang="en-US"/>
               <a:t>Third level</a:t>
             </a:r>
           </a:p>
           <a:p>
             <a:pPr lvl="3"/>
             <a:r>
-              <a:rPr lang="en-US" smtClean="0"/>
+              <a:rPr lang="en-US"/>
               <a:t>Fourth level</a:t>
             </a:r>
           </a:p>
           <a:p>
             <a:pPr lvl="4"/>
             <a:r>
-              <a:rPr lang="en-US" smtClean="0"/>
+              <a:rPr lang="en-US"/>
               <a:t>Fifth level</a:t>
             </a:r>
-            <a:endParaRPr lang="en-US"/>
           </a:p>
         </p:txBody>
       </p:sp>
@@ -1667,7 +1669,7 @@
           <a:p>
             <a:pPr lvl="0"/>
             <a:r>
-              <a:rPr lang="en-US" smtClean="0"/>
+              <a:rPr lang="en-US"/>
               <a:t>Click to edit Master text styles</a:t>
             </a:r>
           </a:p>
@@ -1723,38 +1725,37 @@
           <a:p>
             <a:pPr lvl="0"/>
             <a:r>
-              <a:rPr lang="en-US" smtClean="0"/>
+              <a:rPr lang="en-US"/>
               <a:t>Click to edit Master text styles</a:t>
             </a:r>
           </a:p>
           <a:p>
             <a:pPr lvl="1"/>
             <a:r>
-              <a:rPr lang="en-US" smtClean="0"/>
+              <a:rPr lang="en-US"/>
               <a:t>Second level</a:t>
             </a:r>
           </a:p>
           <a:p>
             <a:pPr lvl="2"/>
             <a:r>
-              <a:rPr lang="en-US" smtClean="0"/>
+              <a:rPr lang="en-US"/>
               <a:t>Third level</a:t>
             </a:r>
           </a:p>
           <a:p>
             <a:pPr lvl="3"/>
             <a:r>
-              <a:rPr lang="en-US" smtClean="0"/>
+              <a:rPr lang="en-US"/>
               <a:t>Fourth level</a:t>
             </a:r>
           </a:p>
           <a:p>
             <a:pPr lvl="4"/>
             <a:r>
-              <a:rPr lang="en-US" smtClean="0"/>
+              <a:rPr lang="en-US"/>
               <a:t>Fifth level</a:t>
             </a:r>
-            <a:endParaRPr lang="en-US"/>
           </a:p>
         </p:txBody>
       </p:sp>
@@ -1775,7 +1776,7 @@
           <a:p>
             <a:fld id="{5BCAD085-E8A6-8845-BD4E-CB4CCA059FC4}" type="datetimeFigureOut">
               <a:rPr lang="en-US" smtClean="0"/>
-              <a:t>1/27/13</a:t>
+              <a:t>5/7/26</a:t>
             </a:fld>
             <a:endParaRPr lang="en-US"/>
           </a:p>
@@ -1869,10 +1870,9 @@
           <a:lstStyle/>
           <a:p>
             <a:r>
-              <a:rPr lang="en-US" smtClean="0"/>
+              <a:rPr lang="en-US"/>
               <a:t>Click to edit Master title style</a:t>
             </a:r>
-            <a:endParaRPr lang="en-US"/>
           </a:p>
         </p:txBody>
       </p:sp>
@@ -1893,7 +1893,7 @@
           <a:p>
             <a:fld id="{5BCAD085-E8A6-8845-BD4E-CB4CCA059FC4}" type="datetimeFigureOut">
               <a:rPr lang="en-US" smtClean="0"/>
-              <a:t>1/27/13</a:t>
+              <a:t>5/7/26</a:t>
             </a:fld>
             <a:endParaRPr lang="en-US"/>
           </a:p>
@@ -1988,7 +1988,7 @@
           <a:p>
             <a:fld id="{5BCAD085-E8A6-8845-BD4E-CB4CCA059FC4}" type="datetimeFigureOut">
               <a:rPr lang="en-US" smtClean="0"/>
-              <a:t>1/27/13</a:t>
+              <a:t>5/7/26</a:t>
             </a:fld>
             <a:endParaRPr lang="en-US"/>
           </a:p>
@@ -2091,10 +2091,9 @@
           </a:lstStyle>
           <a:p>
             <a:r>
-              <a:rPr lang="en-US" smtClean="0"/>
+              <a:rPr lang="en-US"/>
               <a:t>Click to edit Master title style</a:t>
             </a:r>
-            <a:endParaRPr lang="en-US"/>
           </a:p>
         </p:txBody>
       </p:sp>
@@ -2148,38 +2147,37 @@
           <a:p>
             <a:pPr lvl="0"/>
             <a:r>
-              <a:rPr lang="en-US" smtClean="0"/>
+              <a:rPr lang="en-US"/>
               <a:t>Click to edit Master text styles</a:t>
             </a:r>
           </a:p>
           <a:p>
             <a:pPr lvl="1"/>
             <a:r>
-              <a:rPr lang="en-US" smtClean="0"/>
+              <a:rPr lang="en-US"/>
               <a:t>Second level</a:t>
             </a:r>
           </a:p>
           <a:p>
             <a:pPr lvl="2"/>
             <a:r>
-              <a:rPr lang="en-US" smtClean="0"/>
+              <a:rPr lang="en-US"/>
               <a:t>Third level</a:t>
             </a:r>
           </a:p>
           <a:p>
             <a:pPr lvl="3"/>
             <a:r>
-              <a:rPr lang="en-US" smtClean="0"/>
+              <a:rPr lang="en-US"/>
               <a:t>Fourth level</a:t>
             </a:r>
           </a:p>
           <a:p>
             <a:pPr lvl="4"/>
             <a:r>
-              <a:rPr lang="en-US" smtClean="0"/>
+              <a:rPr lang="en-US"/>
               <a:t>Fifth level</a:t>
             </a:r>
-            <a:endParaRPr lang="en-US"/>
           </a:p>
         </p:txBody>
       </p:sp>
@@ -2242,7 +2240,7 @@
           <a:p>
             <a:pPr lvl="0"/>
             <a:r>
-              <a:rPr lang="en-US" smtClean="0"/>
+              <a:rPr lang="en-US"/>
               <a:t>Click to edit Master text styles</a:t>
             </a:r>
           </a:p>
@@ -2265,7 +2263,7 @@
           <a:p>
             <a:fld id="{5BCAD085-E8A6-8845-BD4E-CB4CCA059FC4}" type="datetimeFigureOut">
               <a:rPr lang="en-US" smtClean="0"/>
-              <a:t>1/27/13</a:t>
+              <a:t>5/7/26</a:t>
             </a:fld>
             <a:endParaRPr lang="en-US"/>
           </a:p>
@@ -2368,10 +2366,9 @@
           </a:lstStyle>
           <a:p>
             <a:r>
-              <a:rPr lang="en-US" smtClean="0"/>
+              <a:rPr lang="en-US"/>
               <a:t>Click to edit Master title style</a:t>
             </a:r>
-            <a:endParaRPr lang="en-US"/>
           </a:p>
         </p:txBody>
       </p:sp>
@@ -2495,7 +2492,7 @@
           <a:p>
             <a:pPr lvl="0"/>
             <a:r>
-              <a:rPr lang="en-US" smtClean="0"/>
+              <a:rPr lang="en-US"/>
               <a:t>Click to edit Master text styles</a:t>
             </a:r>
           </a:p>
@@ -2518,7 +2515,7 @@
           <a:p>
             <a:fld id="{5BCAD085-E8A6-8845-BD4E-CB4CCA059FC4}" type="datetimeFigureOut">
               <a:rPr lang="en-US" smtClean="0"/>
-              <a:t>1/27/13</a:t>
+              <a:t>5/7/26</a:t>
             </a:fld>
             <a:endParaRPr lang="en-US"/>
           </a:p>
@@ -2627,10 +2624,9 @@
           <a:lstStyle/>
           <a:p>
             <a:r>
-              <a:rPr lang="en-US" smtClean="0"/>
+              <a:rPr lang="en-US"/>
               <a:t>Click to edit Master title style</a:t>
             </a:r>
-            <a:endParaRPr lang="en-US"/>
           </a:p>
         </p:txBody>
       </p:sp>
@@ -2661,38 +2657,37 @@
           <a:p>
             <a:pPr lvl="0"/>
             <a:r>
-              <a:rPr lang="en-US" smtClean="0"/>
+              <a:rPr lang="en-US"/>
               <a:t>Click to edit Master text styles</a:t>
             </a:r>
           </a:p>
           <a:p>
             <a:pPr lvl="1"/>
             <a:r>
-              <a:rPr lang="en-US" smtClean="0"/>
+              <a:rPr lang="en-US"/>
               <a:t>Second level</a:t>
             </a:r>
           </a:p>
           <a:p>
             <a:pPr lvl="2"/>
             <a:r>
-              <a:rPr lang="en-US" smtClean="0"/>
+              <a:rPr lang="en-US"/>
               <a:t>Third level</a:t>
             </a:r>
           </a:p>
           <a:p>
             <a:pPr lvl="3"/>
             <a:r>
-              <a:rPr lang="en-US" smtClean="0"/>
+              <a:rPr lang="en-US"/>
               <a:t>Fourth level</a:t>
             </a:r>
           </a:p>
           <a:p>
             <a:pPr lvl="4"/>
             <a:r>
-              <a:rPr lang="en-US" smtClean="0"/>
+              <a:rPr lang="en-US"/>
               <a:t>Fifth level</a:t>
             </a:r>
-            <a:endParaRPr lang="en-US"/>
           </a:p>
         </p:txBody>
       </p:sp>
@@ -2731,7 +2726,7 @@
           <a:p>
             <a:fld id="{5BCAD085-E8A6-8845-BD4E-CB4CCA059FC4}" type="datetimeFigureOut">
               <a:rPr lang="en-US" smtClean="0"/>
-              <a:t>1/27/13</a:t>
+              <a:t>5/7/26</a:t>
             </a:fld>
             <a:endParaRPr lang="en-US"/>
           </a:p>
@@ -3090,7 +3085,7 @@
 </file>
 
 <file path=ppt/slides/slide1.xml><?xml version="1.0" encoding="utf-8"?>
-<p:sld xmlns:a="http://schemas.openxmlformats.org/drawingml/2006/main" xmlns:p="http://schemas.openxmlformats.org/presentationml/2006/main" xmlns:r="http://schemas.openxmlformats.org/officeDocument/2006/relationships">
+<p:sld xmlns:a="http://schemas.openxmlformats.org/drawingml/2006/main" xmlns:r="http://schemas.openxmlformats.org/officeDocument/2006/relationships" xmlns:p="http://schemas.openxmlformats.org/presentationml/2006/main">
   <p:cSld>
     <p:bg>
       <p:bgPr>
@@ -3106,7 +3101,14 @@
         <p:cNvGrpSpPr/>
         <p:nvPr/>
       </p:nvGrpSpPr>
-      <p:grpSpPr/>
+      <p:grpSpPr>
+        <a:xfrm>
+          <a:off x="0" y="0"/>
+          <a:ext cx="0" cy="0"/>
+          <a:chOff x="0" y="0"/>
+          <a:chExt cx="0" cy="0"/>
+        </a:xfrm>
+      </p:grpSpPr>
       <p:sp>
         <p:nvSpPr>
           <p:cNvPr id="2" name="TextBox 1"/>
@@ -3256,7 +3258,7 @@
 </file>
 
 <file path=ppt/slides/slide10.xml><?xml version="1.0" encoding="utf-8"?>
-<p:sld xmlns:a="http://schemas.openxmlformats.org/drawingml/2006/main" xmlns:p="http://schemas.openxmlformats.org/presentationml/2006/main" xmlns:r="http://schemas.openxmlformats.org/officeDocument/2006/relationships">
+<p:sld xmlns:a="http://schemas.openxmlformats.org/drawingml/2006/main" xmlns:r="http://schemas.openxmlformats.org/officeDocument/2006/relationships" xmlns:p="http://schemas.openxmlformats.org/presentationml/2006/main">
   <p:cSld>
     <p:spTree>
       <p:nvGrpSpPr>
@@ -3264,7 +3266,14 @@
         <p:cNvGrpSpPr/>
         <p:nvPr/>
       </p:nvGrpSpPr>
-      <p:grpSpPr/>
+      <p:grpSpPr>
+        <a:xfrm>
+          <a:off x="0" y="0"/>
+          <a:ext cx="0" cy="0"/>
+          <a:chOff x="0" y="0"/>
+          <a:chExt cx="0" cy="0"/>
+        </a:xfrm>
+      </p:grpSpPr>
       <p:sp>
         <p:nvSpPr>
           <p:cNvPr id="2" name="TextBox 1"/>
@@ -4518,7 +4527,7 @@
 </file>
 
 <file path=ppt/slides/slide11.xml><?xml version="1.0" encoding="utf-8"?>
-<p:sld xmlns:a="http://schemas.openxmlformats.org/drawingml/2006/main" xmlns:p="http://schemas.openxmlformats.org/presentationml/2006/main" xmlns:r="http://schemas.openxmlformats.org/officeDocument/2006/relationships">
+<p:sld xmlns:a="http://schemas.openxmlformats.org/drawingml/2006/main" xmlns:r="http://schemas.openxmlformats.org/officeDocument/2006/relationships" xmlns:p="http://schemas.openxmlformats.org/presentationml/2006/main">
   <p:cSld>
     <p:spTree>
       <p:nvGrpSpPr>
@@ -4526,7 +4535,14 @@
         <p:cNvGrpSpPr/>
         <p:nvPr/>
       </p:nvGrpSpPr>
-      <p:grpSpPr/>
+      <p:grpSpPr>
+        <a:xfrm>
+          <a:off x="0" y="0"/>
+          <a:ext cx="0" cy="0"/>
+          <a:chOff x="0" y="0"/>
+          <a:chExt cx="0" cy="0"/>
+        </a:xfrm>
+      </p:grpSpPr>
       <p:sp>
         <p:nvSpPr>
           <p:cNvPr id="2" name="TextBox 1"/>
@@ -4837,7 +4853,16 @@
               </a:defRPr>
             </a:pPr>
             <a:r>
-              <a:t>https://tokamak-ai.ru/docs</a:t>
+              <a:rPr dirty="0"/>
+              <a:t>https://tokamak-</a:t>
+            </a:r>
+            <a:r>
+              <a:rPr dirty="0" err="1"/>
+              <a:t>ai.ru</a:t>
+            </a:r>
+            <a:r>
+              <a:rPr dirty="0"/>
+              <a:t>/docs</a:t>
             </a:r>
           </a:p>
         </p:txBody>
@@ -4956,7 +4981,7 @@
 </file>
 
 <file path=ppt/slides/slide12.xml><?xml version="1.0" encoding="utf-8"?>
-<p:sld xmlns:a="http://schemas.openxmlformats.org/drawingml/2006/main" xmlns:p="http://schemas.openxmlformats.org/presentationml/2006/main" xmlns:r="http://schemas.openxmlformats.org/officeDocument/2006/relationships">
+<p:sld xmlns:a="http://schemas.openxmlformats.org/drawingml/2006/main" xmlns:r="http://schemas.openxmlformats.org/officeDocument/2006/relationships" xmlns:p="http://schemas.openxmlformats.org/presentationml/2006/main">
   <p:cSld>
     <p:bg>
       <p:bgPr>
@@ -4972,7 +4997,14 @@
         <p:cNvGrpSpPr/>
         <p:nvPr/>
       </p:nvGrpSpPr>
-      <p:grpSpPr/>
+      <p:grpSpPr>
+        <a:xfrm>
+          <a:off x="0" y="0"/>
+          <a:ext cx="0" cy="0"/>
+          <a:chOff x="0" y="0"/>
+          <a:chExt cx="0" cy="0"/>
+        </a:xfrm>
+      </p:grpSpPr>
       <p:sp>
         <p:nvSpPr>
           <p:cNvPr id="2" name="TextBox 1"/>
@@ -5087,7 +5119,7 @@
 </file>
 
 <file path=ppt/slides/slide2.xml><?xml version="1.0" encoding="utf-8"?>
-<p:sld xmlns:a="http://schemas.openxmlformats.org/drawingml/2006/main" xmlns:p="http://schemas.openxmlformats.org/presentationml/2006/main" xmlns:r="http://schemas.openxmlformats.org/officeDocument/2006/relationships">
+<p:sld xmlns:a="http://schemas.openxmlformats.org/drawingml/2006/main" xmlns:r="http://schemas.openxmlformats.org/officeDocument/2006/relationships" xmlns:p="http://schemas.openxmlformats.org/presentationml/2006/main">
   <p:cSld>
     <p:spTree>
       <p:nvGrpSpPr>
@@ -5095,7 +5127,14 @@
         <p:cNvGrpSpPr/>
         <p:nvPr/>
       </p:nvGrpSpPr>
-      <p:grpSpPr/>
+      <p:grpSpPr>
+        <a:xfrm>
+          <a:off x="0" y="0"/>
+          <a:ext cx="0" cy="0"/>
+          <a:chOff x="0" y="0"/>
+          <a:chExt cx="0" cy="0"/>
+        </a:xfrm>
+      </p:grpSpPr>
       <p:sp>
         <p:nvSpPr>
           <p:cNvPr id="2" name="TextBox 1"/>
@@ -5169,7 +5208,7 @@
           </a:fontRef>
         </p:style>
         <p:txBody>
-          <a:bodyPr rtlCol="0" anchor="ctr" wrap="square"/>
+          <a:bodyPr wrap="square" rtlCol="0" anchor="ctr"/>
           <a:lstStyle/>
           <a:p>
             <a:pPr algn="ctr">
@@ -5298,7 +5337,7 @@
           </a:fontRef>
         </p:style>
         <p:txBody>
-          <a:bodyPr rtlCol="0" anchor="ctr" wrap="square"/>
+          <a:bodyPr wrap="square" rtlCol="0" anchor="ctr"/>
           <a:lstStyle/>
           <a:p>
             <a:pPr algn="ctr">
@@ -5427,7 +5466,7 @@
           </a:fontRef>
         </p:style>
         <p:txBody>
-          <a:bodyPr rtlCol="0" anchor="ctr" wrap="square"/>
+          <a:bodyPr wrap="square" rtlCol="0" anchor="ctr"/>
           <a:lstStyle/>
           <a:p>
             <a:pPr algn="ctr">
@@ -5527,7 +5566,7 @@
 </file>
 
 <file path=ppt/slides/slide3.xml><?xml version="1.0" encoding="utf-8"?>
-<p:sld xmlns:a="http://schemas.openxmlformats.org/drawingml/2006/main" xmlns:p="http://schemas.openxmlformats.org/presentationml/2006/main" xmlns:r="http://schemas.openxmlformats.org/officeDocument/2006/relationships">
+<p:sld xmlns:a="http://schemas.openxmlformats.org/drawingml/2006/main" xmlns:r="http://schemas.openxmlformats.org/officeDocument/2006/relationships" xmlns:p="http://schemas.openxmlformats.org/presentationml/2006/main">
   <p:cSld>
     <p:spTree>
       <p:nvGrpSpPr>
@@ -5535,7 +5574,14 @@
         <p:cNvGrpSpPr/>
         <p:nvPr/>
       </p:nvGrpSpPr>
-      <p:grpSpPr/>
+      <p:grpSpPr>
+        <a:xfrm>
+          <a:off x="0" y="0"/>
+          <a:ext cx="0" cy="0"/>
+          <a:chOff x="0" y="0"/>
+          <a:chExt cx="0" cy="0"/>
+        </a:xfrm>
+      </p:grpSpPr>
       <p:sp>
         <p:nvSpPr>
           <p:cNvPr id="2" name="TextBox 1"/>
@@ -6172,7 +6218,7 @@
 </file>
 
 <file path=ppt/slides/slide4.xml><?xml version="1.0" encoding="utf-8"?>
-<p:sld xmlns:a="http://schemas.openxmlformats.org/drawingml/2006/main" xmlns:p="http://schemas.openxmlformats.org/presentationml/2006/main" xmlns:r="http://schemas.openxmlformats.org/officeDocument/2006/relationships">
+<p:sld xmlns:a="http://schemas.openxmlformats.org/drawingml/2006/main" xmlns:r="http://schemas.openxmlformats.org/officeDocument/2006/relationships" xmlns:p="http://schemas.openxmlformats.org/presentationml/2006/main">
   <p:cSld>
     <p:spTree>
       <p:nvGrpSpPr>
@@ -6180,7 +6226,14 @@
         <p:cNvGrpSpPr/>
         <p:nvPr/>
       </p:nvGrpSpPr>
-      <p:grpSpPr/>
+      <p:grpSpPr>
+        <a:xfrm>
+          <a:off x="0" y="0"/>
+          <a:ext cx="0" cy="0"/>
+          <a:chOff x="0" y="0"/>
+          <a:chExt cx="0" cy="0"/>
+        </a:xfrm>
+      </p:grpSpPr>
       <p:sp>
         <p:nvSpPr>
           <p:cNvPr id="2" name="TextBox 1"/>
@@ -6904,7 +6957,7 @@
 </file>
 
 <file path=ppt/slides/slide5.xml><?xml version="1.0" encoding="utf-8"?>
-<p:sld xmlns:a="http://schemas.openxmlformats.org/drawingml/2006/main" xmlns:p="http://schemas.openxmlformats.org/presentationml/2006/main" xmlns:r="http://schemas.openxmlformats.org/officeDocument/2006/relationships">
+<p:sld xmlns:a="http://schemas.openxmlformats.org/drawingml/2006/main" xmlns:r="http://schemas.openxmlformats.org/officeDocument/2006/relationships" xmlns:p="http://schemas.openxmlformats.org/presentationml/2006/main">
   <p:cSld>
     <p:spTree>
       <p:nvGrpSpPr>
@@ -6912,7 +6965,14 @@
         <p:cNvGrpSpPr/>
         <p:nvPr/>
       </p:nvGrpSpPr>
-      <p:grpSpPr/>
+      <p:grpSpPr>
+        <a:xfrm>
+          <a:off x="0" y="0"/>
+          <a:ext cx="0" cy="0"/>
+          <a:chOff x="0" y="0"/>
+          <a:chExt cx="0" cy="0"/>
+        </a:xfrm>
+      </p:grpSpPr>
       <p:sp>
         <p:nvSpPr>
           <p:cNvPr id="2" name="TextBox 1"/>
@@ -7549,7 +7609,7 @@
 </file>
 
 <file path=ppt/slides/slide6.xml><?xml version="1.0" encoding="utf-8"?>
-<p:sld xmlns:a="http://schemas.openxmlformats.org/drawingml/2006/main" xmlns:p="http://schemas.openxmlformats.org/presentationml/2006/main" xmlns:r="http://schemas.openxmlformats.org/officeDocument/2006/relationships">
+<p:sld xmlns:a="http://schemas.openxmlformats.org/drawingml/2006/main" xmlns:r="http://schemas.openxmlformats.org/officeDocument/2006/relationships" xmlns:p="http://schemas.openxmlformats.org/presentationml/2006/main">
   <p:cSld>
     <p:spTree>
       <p:nvGrpSpPr>
@@ -7557,7 +7617,14 @@
         <p:cNvGrpSpPr/>
         <p:nvPr/>
       </p:nvGrpSpPr>
-      <p:grpSpPr/>
+      <p:grpSpPr>
+        <a:xfrm>
+          <a:off x="0" y="0"/>
+          <a:ext cx="0" cy="0"/>
+          <a:chOff x="0" y="0"/>
+          <a:chExt cx="0" cy="0"/>
+        </a:xfrm>
+      </p:grpSpPr>
       <p:sp>
         <p:nvSpPr>
           <p:cNvPr id="2" name="TextBox 1"/>
@@ -8107,7 +8174,7 @@
 </file>
 
 <file path=ppt/slides/slide7.xml><?xml version="1.0" encoding="utf-8"?>
-<p:sld xmlns:a="http://schemas.openxmlformats.org/drawingml/2006/main" xmlns:p="http://schemas.openxmlformats.org/presentationml/2006/main" xmlns:r="http://schemas.openxmlformats.org/officeDocument/2006/relationships">
+<p:sld xmlns:a="http://schemas.openxmlformats.org/drawingml/2006/main" xmlns:r="http://schemas.openxmlformats.org/officeDocument/2006/relationships" xmlns:p="http://schemas.openxmlformats.org/presentationml/2006/main">
   <p:cSld>
     <p:spTree>
       <p:nvGrpSpPr>
@@ -8115,7 +8182,14 @@
         <p:cNvGrpSpPr/>
         <p:nvPr/>
       </p:nvGrpSpPr>
-      <p:grpSpPr/>
+      <p:grpSpPr>
+        <a:xfrm>
+          <a:off x="0" y="0"/>
+          <a:ext cx="0" cy="0"/>
+          <a:chOff x="0" y="0"/>
+          <a:chExt cx="0" cy="0"/>
+        </a:xfrm>
+      </p:grpSpPr>
       <p:sp>
         <p:nvSpPr>
           <p:cNvPr id="2" name="TextBox 1"/>
@@ -8752,7 +8826,7 @@
 </file>
 
 <file path=ppt/slides/slide8.xml><?xml version="1.0" encoding="utf-8"?>
-<p:sld xmlns:a="http://schemas.openxmlformats.org/drawingml/2006/main" xmlns:p="http://schemas.openxmlformats.org/presentationml/2006/main" xmlns:r="http://schemas.openxmlformats.org/officeDocument/2006/relationships">
+<p:sld xmlns:a="http://schemas.openxmlformats.org/drawingml/2006/main" xmlns:r="http://schemas.openxmlformats.org/officeDocument/2006/relationships" xmlns:p="http://schemas.openxmlformats.org/presentationml/2006/main">
   <p:cSld>
     <p:spTree>
       <p:nvGrpSpPr>
@@ -8760,7 +8834,14 @@
         <p:cNvGrpSpPr/>
         <p:nvPr/>
       </p:nvGrpSpPr>
-      <p:grpSpPr/>
+      <p:grpSpPr>
+        <a:xfrm>
+          <a:off x="0" y="0"/>
+          <a:ext cx="0" cy="0"/>
+          <a:chOff x="0" y="0"/>
+          <a:chExt cx="0" cy="0"/>
+        </a:xfrm>
+      </p:grpSpPr>
       <p:sp>
         <p:nvSpPr>
           <p:cNvPr id="2" name="TextBox 1"/>
@@ -8834,7 +8915,7 @@
           </a:fontRef>
         </p:style>
         <p:txBody>
-          <a:bodyPr rtlCol="0" anchor="ctr" wrap="square"/>
+          <a:bodyPr wrap="square" rtlCol="0" anchor="ctr"/>
           <a:lstStyle/>
           <a:p>
             <a:pPr algn="ctr">
@@ -8888,7 +8969,7 @@
           </a:fontRef>
         </p:style>
         <p:txBody>
-          <a:bodyPr rtlCol="0" anchor="ctr" wrap="square"/>
+          <a:bodyPr wrap="square" rtlCol="0" anchor="ctr"/>
           <a:lstStyle/>
           <a:p>
             <a:pPr algn="ctr">
@@ -8942,7 +9023,7 @@
           </a:fontRef>
         </p:style>
         <p:txBody>
-          <a:bodyPr rtlCol="0" anchor="ctr" wrap="square"/>
+          <a:bodyPr wrap="square" rtlCol="0" anchor="ctr"/>
           <a:lstStyle/>
           <a:p>
             <a:pPr algn="ctr">
@@ -9008,7 +9089,7 @@
           </a:fontRef>
         </p:style>
         <p:txBody>
-          <a:bodyPr rtlCol="0" anchor="ctr" wrap="square"/>
+          <a:bodyPr wrap="square" rtlCol="0" anchor="ctr"/>
           <a:lstStyle/>
           <a:p>
             <a:pPr algn="ctr">
@@ -9074,7 +9155,7 @@
           </a:fontRef>
         </p:style>
         <p:txBody>
-          <a:bodyPr rtlCol="0" anchor="ctr" wrap="square"/>
+          <a:bodyPr wrap="square" rtlCol="0" anchor="ctr"/>
           <a:lstStyle/>
           <a:p>
             <a:pPr algn="ctr">
@@ -9140,7 +9221,7 @@
           </a:fontRef>
         </p:style>
         <p:txBody>
-          <a:bodyPr rtlCol="0" anchor="ctr" wrap="square"/>
+          <a:bodyPr wrap="square" rtlCol="0" anchor="ctr"/>
           <a:lstStyle/>
           <a:p>
             <a:pPr algn="ctr">
@@ -9194,7 +9275,7 @@
           </a:fontRef>
         </p:style>
         <p:txBody>
-          <a:bodyPr rtlCol="0" anchor="ctr" wrap="square"/>
+          <a:bodyPr wrap="square" rtlCol="0" anchor="ctr"/>
           <a:lstStyle/>
           <a:p>
             <a:pPr algn="ctr">
@@ -9260,7 +9341,7 @@
           </a:fontRef>
         </p:style>
         <p:txBody>
-          <a:bodyPr rtlCol="0" anchor="ctr" wrap="square"/>
+          <a:bodyPr wrap="square" rtlCol="0" anchor="ctr"/>
           <a:lstStyle/>
           <a:p>
             <a:pPr algn="ctr">
@@ -9326,7 +9407,7 @@
           </a:fontRef>
         </p:style>
         <p:txBody>
-          <a:bodyPr rtlCol="0" anchor="ctr" wrap="square"/>
+          <a:bodyPr wrap="square" rtlCol="0" anchor="ctr"/>
           <a:lstStyle/>
           <a:p>
             <a:pPr algn="ctr">
@@ -9392,7 +9473,7 @@
           </a:fontRef>
         </p:style>
         <p:txBody>
-          <a:bodyPr rtlCol="0" anchor="ctr" wrap="square"/>
+          <a:bodyPr wrap="square" rtlCol="0" anchor="ctr"/>
           <a:lstStyle/>
           <a:p>
             <a:pPr algn="ctr">
@@ -9458,7 +9539,7 @@
           </a:fontRef>
         </p:style>
         <p:txBody>
-          <a:bodyPr rtlCol="0" anchor="ctr" wrap="square"/>
+          <a:bodyPr wrap="square" rtlCol="0" anchor="ctr"/>
           <a:lstStyle/>
           <a:p>
             <a:pPr algn="ctr">
@@ -9530,7 +9611,7 @@
 </file>
 
 <file path=ppt/slides/slide9.xml><?xml version="1.0" encoding="utf-8"?>
-<p:sld xmlns:a="http://schemas.openxmlformats.org/drawingml/2006/main" xmlns:p="http://schemas.openxmlformats.org/presentationml/2006/main" xmlns:r="http://schemas.openxmlformats.org/officeDocument/2006/relationships">
+<p:sld xmlns:a="http://schemas.openxmlformats.org/drawingml/2006/main" xmlns:r="http://schemas.openxmlformats.org/officeDocument/2006/relationships" xmlns:p="http://schemas.openxmlformats.org/presentationml/2006/main">
   <p:cSld>
     <p:spTree>
       <p:nvGrpSpPr>
@@ -9538,7 +9619,14 @@
         <p:cNvGrpSpPr/>
         <p:nvPr/>
       </p:nvGrpSpPr>
-      <p:grpSpPr/>
+      <p:grpSpPr>
+        <a:xfrm>
+          <a:off x="0" y="0"/>
+          <a:ext cx="0" cy="0"/>
+          <a:chOff x="0" y="0"/>
+          <a:chExt cx="0" cy="0"/>
+        </a:xfrm>
+      </p:grpSpPr>
       <p:sp>
         <p:nvSpPr>
           <p:cNvPr id="2" name="TextBox 1"/>

</xml_diff>